<commit_message>
publish proof-bound NodeKit campaign
</commit_message>
<xml_diff>
--- a/changes/nodekit-proof-campaign-2026-07-20/presentation/exports/nodekit-proof-campaign-2026-07-20.final.pptx
+++ b/changes/nodekit-proof-campaign-2026-07-20/presentation/exports/nodekit-proof-campaign-2026-07-20.final.pptx
@@ -800,7 +800,7 @@
 Citation: https://github.com/HomenShum/founder-quest-graph/releases/tag/v0.1.1-production-certified
 URL: https://github.com/HomenShum/founder-quest-graph/releases/tag/v0.1.1-production-certified
 Disclaimer: User-supplied linked evidence; verify reuse rights before external publication.
-[source_d6a876ec9d0ee0bb1d53d0fead947b6b] NodeKit governed Change Story
+[source_ae2a432e25f101a2a607e32a89c668b3] NodeKit governed Change Story
 Citation: Uploaded file: NodeKit governed Change Story
 {
   "change": {
@@ -1021,9 +1021,9 @@
           "The walkthrough proves one synthetic read-only production journey, not an external outcome or publication."
         ],
         "scope": {
-          "campaignCommit": "7ca02bc3bb73b55ea5c9991276ca1c36268551f8",
-          "technicalSha256": "d0e2d13ed29fc82d6528c988cd6afabf81d464c00d1a80857951377cc8d07e18",
-          "verticalSha256": "4cd8e5c9e5ecfc3b93abaa3e9f8e60dd819c024e6ad147002637bd6e68b12ae3"
+          "campaignCommit": "f002870ab08faaf992677589216d4384211fd1e1",
+          "technicalSha256": "b3b10fcc7ed9bce329aa608ae42294886d6db9b6ff1882bd34e2873ffc1b7ea1",
+          "verticalSha256": "7733c39be6493807459c018931130ccbfed02a6d27659c5a28d60e971591b31d"
         },
         "status": "verified",
         "text": "NodeKit produced and verified an 83-second vertical walkthrough and a 180-second technical walkthrough from the exact Founder Quest production capture, with burned-in narrative text and content-addressed receipts."
@@ -1073,7 +1073,7 @@
   }
 }
 Disclaimer: User supplied
-[source_5137508453e4fbe272bad4a2a6cc649b] NodeKit evidence index
+[source_85565808909cf50cac36ba4cb92d6297] NodeKit evidence index
 Citation: Uploaded file: NodeKit evidence index
 {
   "evidence": [
@@ -1170,27 +1170,27 @@
     {
       "assets": [
         {
-          "bytes": 9771396,
+          "bytes": 9958725,
           "dimensions": "1080x1920",
           "durationSeconds": 83.050667,
           "path": "changes/nodekit-proof-campaign-2026-07-20/video/output/nodekit-founder-quest-vertical.mp4",
-          "sha256": "4cd8e5c9e5ecfc3b93abaa3e9f8e60dd819c024e6ad147002637bd6e68b12ae3"
+          "sha256": "7733c39be6493807459c018931130ccbfed02a6d27659c5a28d60e971591b31d"
         },
         {
-          "bytes": 23095701,
+          "bytes": 23406403,
           "dimensions": "1920x1080",
           "durationSeconds": 180.053333,
           "path": "changes/nodekit-proof-campaign-2026-07-20/video/output/nodekit-founder-quest-technical.mp4",
-          "sha256": "d0e2d13ed29fc82d6528c988cd6afabf81d464c00d1a80857951377cc8d07e18"
+          "sha256": "b3b10fcc7ed9bce329aa608ae42294886d6db9b6ff1882bd34e2873ffc1b7ea1"
         }
       ],
       "id": "E14_FOUNDER_QUEST_VIDEO_PROOF",
       "kind": "media-proof",
       "path": "changes/nodekit-proof-campaign-2026-07-20/video/proof/founder-quest-video-receipt.json",
       "scope": "Feature Proof Studio @ 7aafb3e0a48f3c1e74e69a51d9df506186ea4340; exact Founder Quest deployment dpl_z1dRn48GFzZYuEyBq6oDNKPHdUHP; sampled encoded-frame visual QA passed",
-      "sha256": "25f92d97dcadb31b4b8adee496adee076b0779552bf21cf5c2991f387ed0fb08",
+      "sha256": "d6371b27e858ed4f32c9904c9ed00a64f1acfa69155ad9a2f9af71f59f365f2e",
       "visualQaPath": "changes/nodekit-proof-campaign-2026-07-20/video/proof/founder-quest-media-visual-qa.json",
-      "visualQaSha256": "e4131e974a8b6b2ada07ea2c08ffad97364327a695bc44edaf95ba44ca3704f5"
+      "visualQaSha256": "32f31f2746c9d5032267c0997df074e717cd30a50aae35cd4ef6c6e7132ead15"
     }
   ],
   "schemaVersion": "nodekit.evidence-index/v1"
@@ -1556,7 +1556,7 @@
 Citation: https://github.com/HomenShum/founder-quest-graph/releases/tag/v0.1.1-production-certified
 URL: https://github.com/HomenShum/founder-quest-graph/releases/tag/v0.1.1-production-certified
 Disclaimer: User-supplied linked evidence; verify reuse rights before external publication.
-[source_d6a876ec9d0ee0bb1d53d0fead947b6b] NodeKit governed Change Story
+[source_ae2a432e25f101a2a607e32a89c668b3] NodeKit governed Change Story
 Citation: Uploaded file: NodeKit governed Change Story
 {
   "change": {
@@ -1777,9 +1777,9 @@
           "The walkthrough proves one synthetic read-only production journey, not an external outcome or publication."
         ],
         "scope": {
-          "campaignCommit": "7ca02bc3bb73b55ea5c9991276ca1c36268551f8",
-          "technicalSha256": "d0e2d13ed29fc82d6528c988cd6afabf81d464c00d1a80857951377cc8d07e18",
-          "verticalSha256": "4cd8e5c9e5ecfc3b93abaa3e9f8e60dd819c024e6ad147002637bd6e68b12ae3"
+          "campaignCommit": "f002870ab08faaf992677589216d4384211fd1e1",
+          "technicalSha256": "b3b10fcc7ed9bce329aa608ae42294886d6db9b6ff1882bd34e2873ffc1b7ea1",
+          "verticalSha256": "7733c39be6493807459c018931130ccbfed02a6d27659c5a28d60e971591b31d"
         },
         "status": "verified",
         "text": "NodeKit produced and verified an 83-second vertical walkthrough and a 180-second technical walkthrough from the exact Founder Quest production capture, with burned-in narrative text and content-addressed receipts."
@@ -1829,7 +1829,7 @@
   }
 }
 Disclaimer: User supplied
-[source_5137508453e4fbe272bad4a2a6cc649b] NodeKit evidence index
+[source_85565808909cf50cac36ba4cb92d6297] NodeKit evidence index
 Citation: Uploaded file: NodeKit evidence index
 {
   "evidence": [
@@ -1926,27 +1926,27 @@
     {
       "assets": [
         {
-          "bytes": 9771396,
+          "bytes": 9958725,
           "dimensions": "1080x1920",
           "durationSeconds": 83.050667,
           "path": "changes/nodekit-proof-campaign-2026-07-20/video/output/nodekit-founder-quest-vertical.mp4",
-          "sha256": "4cd8e5c9e5ecfc3b93abaa3e9f8e60dd819c024e6ad147002637bd6e68b12ae3"
+          "sha256": "7733c39be6493807459c018931130ccbfed02a6d27659c5a28d60e971591b31d"
         },
         {
-          "bytes": 23095701,
+          "bytes": 23406403,
           "dimensions": "1920x1080",
           "durationSeconds": 180.053333,
           "path": "changes/nodekit-proof-campaign-2026-07-20/video/output/nodekit-founder-quest-technical.mp4",
-          "sha256": "d0e2d13ed29fc82d6528c988cd6afabf81d464c00d1a80857951377cc8d07e18"
+          "sha256": "b3b10fcc7ed9bce329aa608ae42294886d6db9b6ff1882bd34e2873ffc1b7ea1"
         }
       ],
       "id": "E14_FOUNDER_QUEST_VIDEO_PROOF",
       "kind": "media-proof",
       "path": "changes/nodekit-proof-campaign-2026-07-20/video/proof/founder-quest-video-receipt.json",
       "scope": "Feature Proof Studio @ 7aafb3e0a48f3c1e74e69a51d9df506186ea4340; exact Founder Quest deployment dpl_z1dRn48GFzZYuEyBq6oDNKPHdUHP; sampled encoded-frame visual QA passed",
-      "sha256": "25f92d97dcadb31b4b8adee496adee076b0779552bf21cf5c2991f387ed0fb08",
+      "sha256": "d6371b27e858ed4f32c9904c9ed00a64f1acfa69155ad9a2f9af71f59f365f2e",
       "visualQaPath": "changes/nodekit-proof-campaign-2026-07-20/video/proof/founder-quest-media-visual-qa.json",
-      "visualQaSha256": "e4131e974a8b6b2ada07ea2c08ffad97364327a695bc44edaf95ba44ca3704f5"
+      "visualQaSha256": "32f31f2746c9d5032267c0997df074e717cd30a50aae35cd4ef6c6e7132ead15"
     }
   ],
   "schemaVersion": "nodekit.evidence-index/v1"
@@ -2312,7 +2312,7 @@
 Citation: https://github.com/HomenShum/founder-quest-graph/releases/tag/v0.1.1-production-certified
 URL: https://github.com/HomenShum/founder-quest-graph/releases/tag/v0.1.1-production-certified
 Disclaimer: User-supplied linked evidence; verify reuse rights before external publication.
-[source_d6a876ec9d0ee0bb1d53d0fead947b6b] NodeKit governed Change Story
+[source_ae2a432e25f101a2a607e32a89c668b3] NodeKit governed Change Story
 Citation: Uploaded file: NodeKit governed Change Story
 {
   "change": {
@@ -2533,9 +2533,9 @@
           "The walkthrough proves one synthetic read-only production journey, not an external outcome or publication."
         ],
         "scope": {
-          "campaignCommit": "7ca02bc3bb73b55ea5c9991276ca1c36268551f8",
-          "technicalSha256": "d0e2d13ed29fc82d6528c988cd6afabf81d464c00d1a80857951377cc8d07e18",
-          "verticalSha256": "4cd8e5c9e5ecfc3b93abaa3e9f8e60dd819c024e6ad147002637bd6e68b12ae3"
+          "campaignCommit": "f002870ab08faaf992677589216d4384211fd1e1",
+          "technicalSha256": "b3b10fcc7ed9bce329aa608ae42294886d6db9b6ff1882bd34e2873ffc1b7ea1",
+          "verticalSha256": "7733c39be6493807459c018931130ccbfed02a6d27659c5a28d60e971591b31d"
         },
         "status": "verified",
         "text": "NodeKit produced and verified an 83-second vertical walkthrough and a 180-second technical walkthrough from the exact Founder Quest production capture, with burned-in narrative text and content-addressed receipts."
@@ -2585,7 +2585,7 @@
   }
 }
 Disclaimer: User supplied
-[source_5137508453e4fbe272bad4a2a6cc649b] NodeKit evidence index
+[source_85565808909cf50cac36ba4cb92d6297] NodeKit evidence index
 Citation: Uploaded file: NodeKit evidence index
 {
   "evidence": [
@@ -2682,27 +2682,27 @@
     {
       "assets": [
         {
-          "bytes": 9771396,
+          "bytes": 9958725,
           "dimensions": "1080x1920",
           "durationSeconds": 83.050667,
           "path": "changes/nodekit-proof-campaign-2026-07-20/video/output/nodekit-founder-quest-vertical.mp4",
-          "sha256": "4cd8e5c9e5ecfc3b93abaa3e9f8e60dd819c024e6ad147002637bd6e68b12ae3"
+          "sha256": "7733c39be6493807459c018931130ccbfed02a6d27659c5a28d60e971591b31d"
         },
         {
-          "bytes": 23095701,
+          "bytes": 23406403,
           "dimensions": "1920x1080",
           "durationSeconds": 180.053333,
           "path": "changes/nodekit-proof-campaign-2026-07-20/video/output/nodekit-founder-quest-technical.mp4",
-          "sha256": "d0e2d13ed29fc82d6528c988cd6afabf81d464c00d1a80857951377cc8d07e18"
+          "sha256": "b3b10fcc7ed9bce329aa608ae42294886d6db9b6ff1882bd34e2873ffc1b7ea1"
         }
       ],
       "id": "E14_FOUNDER_QUEST_VIDEO_PROOF",
       "kind": "media-proof",
       "path": "changes/nodekit-proof-campaign-2026-07-20/video/proof/founder-quest-video-receipt.json",
       "scope": "Feature Proof Studio @ 7aafb3e0a48f3c1e74e69a51d9df506186ea4340; exact Founder Quest deployment dpl_z1dRn48GFzZYuEyBq6oDNKPHdUHP; sampled encoded-frame visual QA passed",
-      "sha256": "25f92d97dcadb31b4b8adee496adee076b0779552bf21cf5c2991f387ed0fb08",
+      "sha256": "d6371b27e858ed4f32c9904c9ed00a64f1acfa69155ad9a2f9af71f59f365f2e",
       "visualQaPath": "changes/nodekit-proof-campaign-2026-07-20/video/proof/founder-quest-media-visual-qa.json",
-      "visualQaSha256": "e4131e974a8b6b2ada07ea2c08ffad97364327a695bc44edaf95ba44ca3704f5"
+      "visualQaSha256": "32f31f2746c9d5032267c0997df074e717cd30a50aae35cd4ef6c6e7132ead15"
     }
   ],
   "schemaVersion": "nodekit.evidence-index/v1"
@@ -3068,7 +3068,7 @@
 Citation: https://github.com/HomenShum/founder-quest-graph/releases/tag/v0.1.1-production-certified
 URL: https://github.com/HomenShum/founder-quest-graph/releases/tag/v0.1.1-production-certified
 Disclaimer: User-supplied linked evidence; verify reuse rights before external publication.
-[source_d6a876ec9d0ee0bb1d53d0fead947b6b] NodeKit governed Change Story
+[source_ae2a432e25f101a2a607e32a89c668b3] NodeKit governed Change Story
 Citation: Uploaded file: NodeKit governed Change Story
 {
   "change": {
@@ -3289,9 +3289,9 @@
           "The walkthrough proves one synthetic read-only production journey, not an external outcome or publication."
         ],
         "scope": {
-          "campaignCommit": "7ca02bc3bb73b55ea5c9991276ca1c36268551f8",
-          "technicalSha256": "d0e2d13ed29fc82d6528c988cd6afabf81d464c00d1a80857951377cc8d07e18",
-          "verticalSha256": "4cd8e5c9e5ecfc3b93abaa3e9f8e60dd819c024e6ad147002637bd6e68b12ae3"
+          "campaignCommit": "f002870ab08faaf992677589216d4384211fd1e1",
+          "technicalSha256": "b3b10fcc7ed9bce329aa608ae42294886d6db9b6ff1882bd34e2873ffc1b7ea1",
+          "verticalSha256": "7733c39be6493807459c018931130ccbfed02a6d27659c5a28d60e971591b31d"
         },
         "status": "verified",
         "text": "NodeKit produced and verified an 83-second vertical walkthrough and a 180-second technical walkthrough from the exact Founder Quest production capture, with burned-in narrative text and content-addressed receipts."
@@ -3341,7 +3341,7 @@
   }
 }
 Disclaimer: User supplied
-[source_5137508453e4fbe272bad4a2a6cc649b] NodeKit evidence index
+[source_85565808909cf50cac36ba4cb92d6297] NodeKit evidence index
 Citation: Uploaded file: NodeKit evidence index
 {
   "evidence": [
@@ -3438,27 +3438,27 @@
     {
       "assets": [
         {
-          "bytes": 9771396,
+          "bytes": 9958725,
           "dimensions": "1080x1920",
           "durationSeconds": 83.050667,
           "path": "changes/nodekit-proof-campaign-2026-07-20/video/output/nodekit-founder-quest-vertical.mp4",
-          "sha256": "4cd8e5c9e5ecfc3b93abaa3e9f8e60dd819c024e6ad147002637bd6e68b12ae3"
+          "sha256": "7733c39be6493807459c018931130ccbfed02a6d27659c5a28d60e971591b31d"
         },
         {
-          "bytes": 23095701,
+          "bytes": 23406403,
           "dimensions": "1920x1080",
           "durationSeconds": 180.053333,
           "path": "changes/nodekit-proof-campaign-2026-07-20/video/output/nodekit-founder-quest-technical.mp4",
-          "sha256": "d0e2d13ed29fc82d6528c988cd6afabf81d464c00d1a80857951377cc8d07e18"
+          "sha256": "b3b10fcc7ed9bce329aa608ae42294886d6db9b6ff1882bd34e2873ffc1b7ea1"
         }
       ],
       "id": "E14_FOUNDER_QUEST_VIDEO_PROOF",
       "kind": "media-proof",
       "path": "changes/nodekit-proof-campaign-2026-07-20/video/proof/founder-quest-video-receipt.json",
       "scope": "Feature Proof Studio @ 7aafb3e0a48f3c1e74e69a51d9df506186ea4340; exact Founder Quest deployment dpl_z1dRn48GFzZYuEyBq6oDNKPHdUHP; sampled encoded-frame visual QA passed",
-      "sha256": "25f92d97dcadb31b4b8adee496adee076b0779552bf21cf5c2991f387ed0fb08",
+      "sha256": "d6371b27e858ed4f32c9904c9ed00a64f1acfa69155ad9a2f9af71f59f365f2e",
       "visualQaPath": "changes/nodekit-proof-campaign-2026-07-20/video/proof/founder-quest-media-visual-qa.json",
-      "visualQaSha256": "e4131e974a8b6b2ada07ea2c08ffad97364327a695bc44edaf95ba44ca3704f5"
+      "visualQaSha256": "32f31f2746c9d5032267c0997df074e717cd30a50aae35cd4ef6c6e7132ead15"
     }
   ],
   "schemaVersion": "nodekit.evidence-index/v1"
@@ -3824,7 +3824,7 @@
 Citation: https://github.com/HomenShum/founder-quest-graph/releases/tag/v0.1.1-production-certified
 URL: https://github.com/HomenShum/founder-quest-graph/releases/tag/v0.1.1-production-certified
 Disclaimer: User-supplied linked evidence; verify reuse rights before external publication.
-[source_d6a876ec9d0ee0bb1d53d0fead947b6b] NodeKit governed Change Story
+[source_ae2a432e25f101a2a607e32a89c668b3] NodeKit governed Change Story
 Citation: Uploaded file: NodeKit governed Change Story
 {
   "change": {
@@ -4045,9 +4045,9 @@
           "The walkthrough proves one synthetic read-only production journey, not an external outcome or publication."
         ],
         "scope": {
-          "campaignCommit": "7ca02bc3bb73b55ea5c9991276ca1c36268551f8",
-          "technicalSha256": "d0e2d13ed29fc82d6528c988cd6afabf81d464c00d1a80857951377cc8d07e18",
-          "verticalSha256": "4cd8e5c9e5ecfc3b93abaa3e9f8e60dd819c024e6ad147002637bd6e68b12ae3"
+          "campaignCommit": "f002870ab08faaf992677589216d4384211fd1e1",
+          "technicalSha256": "b3b10fcc7ed9bce329aa608ae42294886d6db9b6ff1882bd34e2873ffc1b7ea1",
+          "verticalSha256": "7733c39be6493807459c018931130ccbfed02a6d27659c5a28d60e971591b31d"
         },
         "status": "verified",
         "text": "NodeKit produced and verified an 83-second vertical walkthrough and a 180-second technical walkthrough from the exact Founder Quest production capture, with burned-in narrative text and content-addressed receipts."
@@ -4097,7 +4097,7 @@
   }
 }
 Disclaimer: User supplied
-[source_5137508453e4fbe272bad4a2a6cc649b] NodeKit evidence index
+[source_85565808909cf50cac36ba4cb92d6297] NodeKit evidence index
 Citation: Uploaded file: NodeKit evidence index
 {
   "evidence": [
@@ -4194,27 +4194,27 @@
     {
       "assets": [
         {
-          "bytes": 9771396,
+          "bytes": 9958725,
           "dimensions": "1080x1920",
           "durationSeconds": 83.050667,
           "path": "changes/nodekit-proof-campaign-2026-07-20/video/output/nodekit-founder-quest-vertical.mp4",
-          "sha256": "4cd8e5c9e5ecfc3b93abaa3e9f8e60dd819c024e6ad147002637bd6e68b12ae3"
+          "sha256": "7733c39be6493807459c018931130ccbfed02a6d27659c5a28d60e971591b31d"
         },
         {
-          "bytes": 23095701,
+          "bytes": 23406403,
           "dimensions": "1920x1080",
           "durationSeconds": 180.053333,
           "path": "changes/nodekit-proof-campaign-2026-07-20/video/output/nodekit-founder-quest-technical.mp4",
-          "sha256": "d0e2d13ed29fc82d6528c988cd6afabf81d464c00d1a80857951377cc8d07e18"
+          "sha256": "b3b10fcc7ed9bce329aa608ae42294886d6db9b6ff1882bd34e2873ffc1b7ea1"
         }
       ],
       "id": "E14_FOUNDER_QUEST_VIDEO_PROOF",
       "kind": "media-proof",
       "path": "changes/nodekit-proof-campaign-2026-07-20/video/proof/founder-quest-video-receipt.json",
       "scope": "Feature Proof Studio @ 7aafb3e0a48f3c1e74e69a51d9df506186ea4340; exact Founder Quest deployment dpl_z1dRn48GFzZYuEyBq6oDNKPHdUHP; sampled encoded-frame visual QA passed",
-      "sha256": "25f92d97dcadb31b4b8adee496adee076b0779552bf21cf5c2991f387ed0fb08",
+      "sha256": "d6371b27e858ed4f32c9904c9ed00a64f1acfa69155ad9a2f9af71f59f365f2e",
       "visualQaPath": "changes/nodekit-proof-campaign-2026-07-20/video/proof/founder-quest-media-visual-qa.json",
-      "visualQaSha256": "e4131e974a8b6b2ada07ea2c08ffad97364327a695bc44edaf95ba44ca3704f5"
+      "visualQaSha256": "32f31f2746c9d5032267c0997df074e717cd30a50aae35cd4ef6c6e7132ead15"
     }
   ],
   "schemaVersion": "nodekit.evidence-index/v1"
@@ -4587,7 +4587,7 @@
 Citation: https://github.com/HomenShum/founder-quest-graph/releases/tag/v0.1.1-production-certified
 URL: https://github.com/HomenShum/founder-quest-graph/releases/tag/v0.1.1-production-certified
 Disclaimer: User-supplied linked evidence; verify reuse rights before external publication.
-[source_d6a876ec9d0ee0bb1d53d0fead947b6b] NodeKit governed Change Story
+[source_ae2a432e25f101a2a607e32a89c668b3] NodeKit governed Change Story
 Citation: Uploaded file: NodeKit governed Change Story
 {
   "change": {
@@ -4808,9 +4808,9 @@
           "The walkthrough proves one synthetic read-only production journey, not an external outcome or publication."
         ],
         "scope": {
-          "campaignCommit": "7ca02bc3bb73b55ea5c9991276ca1c36268551f8",
-          "technicalSha256": "d0e2d13ed29fc82d6528c988cd6afabf81d464c00d1a80857951377cc8d07e18",
-          "verticalSha256": "4cd8e5c9e5ecfc3b93abaa3e9f8e60dd819c024e6ad147002637bd6e68b12ae3"
+          "campaignCommit": "f002870ab08faaf992677589216d4384211fd1e1",
+          "technicalSha256": "b3b10fcc7ed9bce329aa608ae42294886d6db9b6ff1882bd34e2873ffc1b7ea1",
+          "verticalSha256": "7733c39be6493807459c018931130ccbfed02a6d27659c5a28d60e971591b31d"
         },
         "status": "verified",
         "text": "NodeKit produced and verified an 83-second vertical walkthrough and a 180-second technical walkthrough from the exact Founder Quest production capture, with burned-in narrative text and content-addressed receipts."
@@ -4860,7 +4860,7 @@
   }
 }
 Disclaimer: User supplied
-[source_5137508453e4fbe272bad4a2a6cc649b] NodeKit evidence index
+[source_85565808909cf50cac36ba4cb92d6297] NodeKit evidence index
 Citation: Uploaded file: NodeKit evidence index
 {
   "evidence": [
@@ -4957,27 +4957,27 @@
     {
       "assets": [
         {
-          "bytes": 9771396,
+          "bytes": 9958725,
           "dimensions": "1080x1920",
           "durationSeconds": 83.050667,
           "path": "changes/nodekit-proof-campaign-2026-07-20/video/output/nodekit-founder-quest-vertical.mp4",
-          "sha256": "4cd8e5c9e5ecfc3b93abaa3e9f8e60dd819c024e6ad147002637bd6e68b12ae3"
+          "sha256": "7733c39be6493807459c018931130ccbfed02a6d27659c5a28d60e971591b31d"
         },
         {
-          "bytes": 23095701,
+          "bytes": 23406403,
           "dimensions": "1920x1080",
           "durationSeconds": 180.053333,
           "path": "changes/nodekit-proof-campaign-2026-07-20/video/output/nodekit-founder-quest-technical.mp4",
-          "sha256": "d0e2d13ed29fc82d6528c988cd6afabf81d464c00d1a80857951377cc8d07e18"
+          "sha256": "b3b10fcc7ed9bce329aa608ae42294886d6db9b6ff1882bd34e2873ffc1b7ea1"
         }
       ],
       "id": "E14_FOUNDER_QUEST_VIDEO_PROOF",
       "kind": "media-proof",
       "path": "changes/nodekit-proof-campaign-2026-07-20/video/proof/founder-quest-video-receipt.json",
       "scope": "Feature Proof Studio @ 7aafb3e0a48f3c1e74e69a51d9df506186ea4340; exact Founder Quest deployment dpl_z1dRn48GFzZYuEyBq6oDNKPHdUHP; sampled encoded-frame visual QA passed",
-      "sha256": "25f92d97dcadb31b4b8adee496adee076b0779552bf21cf5c2991f387ed0fb08",
+      "sha256": "d6371b27e858ed4f32c9904c9ed00a64f1acfa69155ad9a2f9af71f59f365f2e",
       "visualQaPath": "changes/nodekit-proof-campaign-2026-07-20/video/proof/founder-quest-media-visual-qa.json",
-      "visualQaSha256": "e4131e974a8b6b2ada07ea2c08ffad97364327a695bc44edaf95ba44ca3704f5"
+      "visualQaSha256": "32f31f2746c9d5032267c0997df074e717cd30a50aae35cd4ef6c6e7132ead15"
     }
   ],
   "schemaVersion": "nodekit.evidence-index/v1"
@@ -5343,7 +5343,7 @@
 Citation: https://github.com/HomenShum/founder-quest-graph/releases/tag/v0.1.1-production-certified
 URL: https://github.com/HomenShum/founder-quest-graph/releases/tag/v0.1.1-production-certified
 Disclaimer: User-supplied linked evidence; verify reuse rights before external publication.
-[source_d6a876ec9d0ee0bb1d53d0fead947b6b] NodeKit governed Change Story
+[source_ae2a432e25f101a2a607e32a89c668b3] NodeKit governed Change Story
 Citation: Uploaded file: NodeKit governed Change Story
 {
   "change": {
@@ -5564,9 +5564,9 @@
           "The walkthrough proves one synthetic read-only production journey, not an external outcome or publication."
         ],
         "scope": {
-          "campaignCommit": "7ca02bc3bb73b55ea5c9991276ca1c36268551f8",
-          "technicalSha256": "d0e2d13ed29fc82d6528c988cd6afabf81d464c00d1a80857951377cc8d07e18",
-          "verticalSha256": "4cd8e5c9e5ecfc3b93abaa3e9f8e60dd819c024e6ad147002637bd6e68b12ae3"
+          "campaignCommit": "f002870ab08faaf992677589216d4384211fd1e1",
+          "technicalSha256": "b3b10fcc7ed9bce329aa608ae42294886d6db9b6ff1882bd34e2873ffc1b7ea1",
+          "verticalSha256": "7733c39be6493807459c018931130ccbfed02a6d27659c5a28d60e971591b31d"
         },
         "status": "verified",
         "text": "NodeKit produced and verified an 83-second vertical walkthrough and a 180-second technical walkthrough from the exact Founder Quest production capture, with burned-in narrative text and content-addressed receipts."
@@ -5616,7 +5616,7 @@
   }
 }
 Disclaimer: User supplied
-[source_5137508453e4fbe272bad4a2a6cc649b] NodeKit evidence index
+[source_85565808909cf50cac36ba4cb92d6297] NodeKit evidence index
 Citation: Uploaded file: NodeKit evidence index
 {
   "evidence": [
@@ -5713,27 +5713,27 @@
     {
       "assets": [
         {
-          "bytes": 9771396,
+          "bytes": 9958725,
           "dimensions": "1080x1920",
           "durationSeconds": 83.050667,
           "path": "changes/nodekit-proof-campaign-2026-07-20/video/output/nodekit-founder-quest-vertical.mp4",
-          "sha256": "4cd8e5c9e5ecfc3b93abaa3e9f8e60dd819c024e6ad147002637bd6e68b12ae3"
+          "sha256": "7733c39be6493807459c018931130ccbfed02a6d27659c5a28d60e971591b31d"
         },
         {
-          "bytes": 23095701,
+          "bytes": 23406403,
           "dimensions": "1920x1080",
           "durationSeconds": 180.053333,
           "path": "changes/nodekit-proof-campaign-2026-07-20/video/output/nodekit-founder-quest-technical.mp4",
-          "sha256": "d0e2d13ed29fc82d6528c988cd6afabf81d464c00d1a80857951377cc8d07e18"
+          "sha256": "b3b10fcc7ed9bce329aa608ae42294886d6db9b6ff1882bd34e2873ffc1b7ea1"
         }
       ],
       "id": "E14_FOUNDER_QUEST_VIDEO_PROOF",
       "kind": "media-proof",
       "path": "changes/nodekit-proof-campaign-2026-07-20/video/proof/founder-quest-video-receipt.json",
       "scope": "Feature Proof Studio @ 7aafb3e0a48f3c1e74e69a51d9df506186ea4340; exact Founder Quest deployment dpl_z1dRn48GFzZYuEyBq6oDNKPHdUHP; sampled encoded-frame visual QA passed",
-      "sha256": "25f92d97dcadb31b4b8adee496adee076b0779552bf21cf5c2991f387ed0fb08",
+      "sha256": "d6371b27e858ed4f32c9904c9ed00a64f1acfa69155ad9a2f9af71f59f365f2e",
       "visualQaPath": "changes/nodekit-proof-campaign-2026-07-20/video/proof/founder-quest-media-visual-qa.json",
-      "visualQaSha256": "e4131e974a8b6b2ada07ea2c08ffad97364327a695bc44edaf95ba44ca3704f5"
+      "visualQaSha256": "32f31f2746c9d5032267c0997df074e717cd30a50aae35cd4ef6c6e7132ead15"
     }
   ],
   "schemaVersion": "nodekit.evidence-index/v1"
@@ -6101,7 +6101,7 @@
 Citation: https://github.com/HomenShum/founder-quest-graph/releases/tag/v0.1.1-production-certified
 URL: https://github.com/HomenShum/founder-quest-graph/releases/tag/v0.1.1-production-certified
 Disclaimer: User-supplied linked evidence; verify reuse rights before external publication.
-[source_d6a876ec9d0ee0bb1d53d0fead947b6b] NodeKit governed Change Story
+[source_ae2a432e25f101a2a607e32a89c668b3] NodeKit governed Change Story
 Citation: Uploaded file: NodeKit governed Change Story
 {
   "change": {
@@ -6322,9 +6322,9 @@
           "The walkthrough proves one synthetic read-only production journey, not an external outcome or publication."
         ],
         "scope": {
-          "campaignCommit": "7ca02bc3bb73b55ea5c9991276ca1c36268551f8",
-          "technicalSha256": "d0e2d13ed29fc82d6528c988cd6afabf81d464c00d1a80857951377cc8d07e18",
-          "verticalSha256": "4cd8e5c9e5ecfc3b93abaa3e9f8e60dd819c024e6ad147002637bd6e68b12ae3"
+          "campaignCommit": "f002870ab08faaf992677589216d4384211fd1e1",
+          "technicalSha256": "b3b10fcc7ed9bce329aa608ae42294886d6db9b6ff1882bd34e2873ffc1b7ea1",
+          "verticalSha256": "7733c39be6493807459c018931130ccbfed02a6d27659c5a28d60e971591b31d"
         },
         "status": "verified",
         "text": "NodeKit produced and verified an 83-second vertical walkthrough and a 180-second technical walkthrough from the exact Founder Quest production capture, with burned-in narrative text and content-addressed receipts."
@@ -6374,7 +6374,7 @@
   }
 }
 Disclaimer: User supplied
-[source_5137508453e4fbe272bad4a2a6cc649b] NodeKit evidence index
+[source_85565808909cf50cac36ba4cb92d6297] NodeKit evidence index
 Citation: Uploaded file: NodeKit evidence index
 {
   "evidence": [
@@ -6471,27 +6471,27 @@
     {
       "assets": [
         {
-          "bytes": 9771396,
+          "bytes": 9958725,
           "dimensions": "1080x1920",
           "durationSeconds": 83.050667,
           "path": "changes/nodekit-proof-campaign-2026-07-20/video/output/nodekit-founder-quest-vertical.mp4",
-          "sha256": "4cd8e5c9e5ecfc3b93abaa3e9f8e60dd819c024e6ad147002637bd6e68b12ae3"
+          "sha256": "7733c39be6493807459c018931130ccbfed02a6d27659c5a28d60e971591b31d"
         },
         {
-          "bytes": 23095701,
+          "bytes": 23406403,
           "dimensions": "1920x1080",
           "durationSeconds": 180.053333,
           "path": "changes/nodekit-proof-campaign-2026-07-20/video/output/nodekit-founder-quest-technical.mp4",
-          "sha256": "d0e2d13ed29fc82d6528c988cd6afabf81d464c00d1a80857951377cc8d07e18"
+          "sha256": "b3b10fcc7ed9bce329aa608ae42294886d6db9b6ff1882bd34e2873ffc1b7ea1"
         }
       ],
       "id": "E14_FOUNDER_QUEST_VIDEO_PROOF",
       "kind": "media-proof",
       "path": "changes/nodekit-proof-campaign-2026-07-20/video/proof/founder-quest-video-receipt.json",
       "scope": "Feature Proof Studio @ 7aafb3e0a48f3c1e74e69a51d9df506186ea4340; exact Founder Quest deployment dpl_z1dRn48GFzZYuEyBq6oDNKPHdUHP; sampled encoded-frame visual QA passed",
-      "sha256": "25f92d97dcadb31b4b8adee496adee076b0779552bf21cf5c2991f387ed0fb08",
+      "sha256": "d6371b27e858ed4f32c9904c9ed00a64f1acfa69155ad9a2f9af71f59f365f2e",
       "visualQaPath": "changes/nodekit-proof-campaign-2026-07-20/video/proof/founder-quest-media-visual-qa.json",
-      "visualQaSha256": "e4131e974a8b6b2ada07ea2c08ffad97364327a695bc44edaf95ba44ca3704f5"
+      "visualQaSha256": "32f31f2746c9d5032267c0997df074e717cd30a50aae35cd4ef6c6e7132ead15"
     }
   ],
   "schemaVersion": "nodekit.evidence-index/v1"

</xml_diff>